<commit_message>
Revisao de materiais SSC: aulas, pacotes de grupos, pipeline e setup
Aulas/apostila:
- Aula 2: bloco LGPD completo + ECA Digital (Lei 15.211/2025) + slide OWASP ASVS
- Aula 3: exemplo trabalhado de DFD com trust boundaries (imagem da p.23)
- Aula 8/apostila/rubrica: assinatura de supply chain (cosign/SLSA L2) agora obrigatoria (Fase 6)

Processo/docs:
- docs/05: 5 grupos independentes; transversais so F-10/F-21
- docs/06: gates Container Scanning (Trivy image) e DAST autenticado (ZAP+JWT); IaC removido;
  revisao de PR intra-grupo; guia detalhado de assinatura (cosign); secao de hardening enxugada
- docs/08: rubrica alinhada (supply chain obrigatoria; L3 sai do bonus)
- docs/09: passo a passo de branch protection (Rulesets) + block force pushes
- .github/workflows: novos gates container-scan e DAST autenticado

Inclui tambem ajustes pendentes de sessao anterior em README, docs/01 e legacy-app/README.

Co-Authored-By: Claude Opus 4.8 <noreply@anthropic.com>
</commit_message>
<xml_diff>
--- a/aulas/aula-08-devsecops.pptx
+++ b/aulas/aula-08-devsecops.pptx
@@ -790,7 +790,7 @@
           <a:lstStyle/>
           <a:p>
             <a:r>
-              <a:t>O pipeline do VidaPlus já sobe com os gates. Nesta fase o grupo o consolida como gerador de EVIDÊNCIA (não como a nota — a nota vem do dossiê e da defesa). Documente quais gates ficaram verdes e tornou bloqueantes, gere o SBOM e, como bônus, assine a imagem. Nem todos os gates precisam ficar verdes — só os das PoCs; os demais sustentam o plano de remediação.</a:t>
+              <a:t>O pipeline do VidaPlus já sobe com os gates. Nesta fase o grupo o consolida como gerador de EVIDÊNCIA (não como a nota — a nota vem do dossiê e da defesa). Documente quais gates ficaram verdes e tornou bloqueantes, gere o SBOM e assine a imagem com cosign (proveniência SLSA L2, obrigatória). Nem todos os gates precisam ficar verdes — só os das PoCs; os demais sustentam o plano de remediação.</a:t>
             </a:r>
           </a:p>
         </p:txBody>
@@ -8015,7 +8015,7 @@
                 </a:solidFill>
                 <a:latin typeface="Open Sans"/>
               </a:rPr>
-              <a:t>Bônus: </a:t>
+              <a:t>Obrigatório: </a:t>
             </a:r>
             <a:r>
               <a:rPr sz="1800">
@@ -8024,7 +8024,7 @@
                 </a:solidFill>
                 <a:latin typeface="Open Sans"/>
               </a:rPr>
-              <a:t>assinar a imagem do backend com cosign (SLSA L2).</a:t>
+              <a:t>assinar a imagem do backend com cosign (proveniência SLSA L2).</a:t>
             </a:r>
           </a:p>
           <a:p>

</xml_diff>

<commit_message>
Defesa detalhada, nota 0-10 sem bonus/penalidade, atestacao de SBOM obrigatoria
- Defesa: rubrica propria (fio ao vivo/privacidade/justificativa/arguicao) + dominio
  individual (fator por integrante); banca = professor; checklist do aluno em docs/10 §11
- Nota convertida para escala 0-10: pesos das fases somam 10; defesa 0-10;
  nota final = 0,8*artefatos + 0,2*defesa*fator individual
- Removidos bonus e penalidades (qualidade entra na nota da propria fase)
- Atestacao do SBOM (cosign attest) agora OBRIGATORIA na Fase 6 (doc 06/08/12 + aula-08)
- Glossario/doc 06: ajustes de "bonus" -> "avancado/opcional"; docs/10 defesa 0-10

Co-Authored-By: Claude Opus 4.8 <noreply@anthropic.com>
</commit_message>
<xml_diff>
--- a/aulas/aula-08-devsecops.pptx
+++ b/aulas/aula-08-devsecops.pptx
@@ -790,7 +790,7 @@
           <a:lstStyle/>
           <a:p>
             <a:r>
-              <a:t>O pipeline do VidaPlus já sobe com os gates. Nesta fase o grupo o consolida como gerador de EVIDÊNCIA (não como a nota — a nota vem do dossiê e da defesa). Documente quais gates ficaram verdes e tornou bloqueantes, gere o SBOM e assine a imagem com cosign (proveniência SLSA L2, obrigatória). Nem todos os gates precisam ficar verdes — só os das PoCs; os demais sustentam o plano de remediação.</a:t>
+              <a:t>O pipeline do VidaPlus já sobe com os gates. Nesta fase o grupo o consolida como gerador de EVIDÊNCIA (não como a nota — a nota vem do dossiê e da defesa). Documente quais gates ficaram verdes e tornou bloqueantes, gere o SBOM, assine a imagem com cosign E ateste o SBOM da imagem (cosign attest) — proveniência SLSA L2, obrigatória. Nem todos os gates precisam ficar verdes — só os das PoCs; os demais sustentam o plano.</a:t>
             </a:r>
           </a:p>
         </p:txBody>
@@ -8024,7 +8024,7 @@
                 </a:solidFill>
                 <a:latin typeface="Open Sans"/>
               </a:rPr>
-              <a:t>imagem do backend assinada com cosign (proveniência SLSA L2).</a:t>
+              <a:t>assinar a imagem (cosign) + atestar o SBOM da imagem -&gt; SLSA L2.</a:t>
             </a:r>
           </a:p>
           <a:p>
@@ -8061,7 +8061,7 @@
                 </a:solidFill>
                 <a:latin typeface="Open Sans"/>
               </a:rPr>
-              <a:t>gates das PoCs verdes + SBOM + assinatura verificada.</a:t>
+              <a:t>gates das PoCs verdes + assinatura e atestação verificadas.</a:t>
             </a:r>
           </a:p>
         </p:txBody>

</xml_diff>

<commit_message>
Pipeline de CD pre-fiado: assinatura/atestacao + staging + verificacao + aprovacao
Objetivo: o aluno NAO configura ferramenta (zero-config via OIDC + GITHUB_TOKEN); o
projeto ja oferece a entrega segura pronta. Reverte o Modelo A (student-built) da assinatura.

- workflow: novos jobs (na main) release-sign (build once -> push GHCR -> cosign sign +
  attest SBOM = SLSA L2) -> deploy-staging (smoke) -> deploy-prod (admission gate:
  cosign verify + verify-attestation recusam imagem nao assinada; aprovacao manual via
  Environment 'production'). deploy-prod com menor privilegio (packages: read).
- doc 06 §5 reescrito: de "construa o job" para "ja vem pronto; use, torne bloqueante,
  explique". doc 09 §5.3: unico passo em Settings (Environment production + reviewer).
- rubrica (F6), apostila e slide aula-08 alinhados (aluno explica/verifica, nao constroi).

Co-Authored-By: Claude Opus 4.8 <noreply@anthropic.com>
</commit_message>
<xml_diff>
--- a/aulas/aula-08-devsecops.pptx
+++ b/aulas/aula-08-devsecops.pptx
@@ -790,7 +790,7 @@
           <a:lstStyle/>
           <a:p>
             <a:r>
-              <a:t>O pipeline do VidaPlus já sobe com os gates. Nesta fase o grupo o consolida como gerador de EVIDÊNCIA (não como a nota — a nota vem do dossiê e da defesa). Documente quais gates ficaram verdes e tornou bloqueantes, gere o SBOM, assine a imagem com cosign E ateste o SBOM da imagem (cosign attest) — proveniência SLSA L2, obrigatória. Nem todos os gates precisam ficar verdes — só os das PoCs; os demais sustentam o plano.</a:t>
+              <a:t>A entrega segura vem PRÉ-FIADA: o aluno não configura ferramenta. Na main, o pipeline faz build once -&gt; publica no GHCR -&gt; assina (cosign keyless) -&gt; atesta o SBOM (SLSA L2) -&gt; sobe staging (smoke/DAST) -&gt; e no deploy-prod VERIFICA a assinatura/atestação (recusa imagem não assinada) e exige APROVAÇÃO manual. O trabalho do grupo é tornar os gates das PoCs bloqueantes e EXPLICAR o fluxo + a evidência (imagem assinada em Packages, verify passando, a pausa de aprovação). Assinar só vale porque alguém verifica.</a:t>
             </a:r>
           </a:p>
         </p:txBody>
@@ -7807,7 +7807,7 @@
                 </a:solidFill>
                 <a:latin typeface="Open Sans"/>
               </a:rPr>
-              <a:t>Pipeline como evidência + assinatura (dossiê §8)</a:t>
+              <a:t>Pipeline como evidência (entrega já pré-fiada) — dossiê §8</a:t>
             </a:r>
           </a:p>
         </p:txBody>
@@ -7904,7 +7904,7 @@
                 </a:solidFill>
                 <a:latin typeface="Open Sans"/>
               </a:rPr>
-              <a:t>Entregar: </a:t>
+              <a:t>Já pronto no pipeline: </a:t>
             </a:r>
             <a:r>
               <a:rPr sz="1800">
@@ -7913,7 +7913,7 @@
                 </a:solidFill>
                 <a:latin typeface="Open Sans"/>
               </a:rPr>
-              <a:t>placar de gates documentado (vermelho -&gt; verde do seu pacote).</a:t>
+              <a:t>release-sign (assina + atesta SBOM) -&gt; staging -&gt; prod.</a:t>
             </a:r>
           </a:p>
           <a:p>
@@ -7941,7 +7941,7 @@
                 </a:solidFill>
                 <a:latin typeface="Open Sans"/>
               </a:rPr>
-              <a:t>SBOM: </a:t>
+              <a:t>Prod só passa: </a:t>
             </a:r>
             <a:r>
               <a:rPr sz="1800">
@@ -7950,7 +7950,7 @@
                 </a:solidFill>
                 <a:latin typeface="Open Sans"/>
               </a:rPr>
-              <a:t>gerado no CI (CycloneDX) e anexado.</a:t>
+              <a:t>com assinatura verificada + aprovação manual (admission gate).</a:t>
             </a:r>
           </a:p>
           <a:p>
@@ -7978,7 +7978,7 @@
                 </a:solidFill>
                 <a:latin typeface="Open Sans"/>
               </a:rPr>
-              <a:t>Sem segredos: </a:t>
+              <a:t>Você NÃO configura: </a:t>
             </a:r>
             <a:r>
               <a:rPr sz="1800">
@@ -7987,7 +7987,7 @@
                 </a:solidFill>
                 <a:latin typeface="Open Sans"/>
               </a:rPr>
-              <a:t>o gate de secret scanning deve ficar verde.</a:t>
+              <a:t>ferramentas usam OIDC + token; sem segredos.</a:t>
             </a:r>
           </a:p>
           <a:p>
@@ -8015,7 +8015,7 @@
                 </a:solidFill>
                 <a:latin typeface="Open Sans"/>
               </a:rPr>
-              <a:t>Obrigatório: </a:t>
+              <a:t>Você faz: </a:t>
             </a:r>
             <a:r>
               <a:rPr sz="1800">
@@ -8024,7 +8024,7 @@
                 </a:solidFill>
                 <a:latin typeface="Open Sans"/>
               </a:rPr>
-              <a:t>assinar a imagem (cosign) + atestar o SBOM da imagem -&gt; SLSA L2.</a:t>
+              <a:t>torna gates bloqueantes + explica o fluxo e a evidência no dossiê.</a:t>
             </a:r>
           </a:p>
           <a:p>
@@ -8052,7 +8052,7 @@
                 </a:solidFill>
                 <a:latin typeface="Open Sans"/>
               </a:rPr>
-              <a:t>Pronto quando: </a:t>
+              <a:t>Setup único: </a:t>
             </a:r>
             <a:r>
               <a:rPr sz="1800">
@@ -8061,7 +8061,7 @@
                 </a:solidFill>
                 <a:latin typeface="Open Sans"/>
               </a:rPr>
-              <a:t>gates das PoCs verdes + assinatura e atestação verificadas.</a:t>
+              <a:t>criar o environment 'production' com revisor (docs/09 §5.3).</a:t>
             </a:r>
           </a:p>
         </p:txBody>

</xml_diff>